<commit_message>
Add timed speaker notes and a presenter split to the deck
Every slide carries notes naming the presenter and a time budget. The budgets
sum to 9 min 45 s, leaving buffer inside the 10 minutes the guidelines allow.

Split: Nitesh takes the problem, literature, conclusions and publication;
Yash takes objectives and method; Sajan takes all three results slides. That
puts each person on their own material rather than passing the clicker
mid-argument.

The notes are cues, not a script. Two of them say explicitly what to do when
a question has no confident answer - the chromatic-dispersion inversion in
particular, where the honest position is that we have an untested hypothesis.

Co-Authored-By: Claude Opus 5 (1M context) <noreply@anthropic.com>
</commit_message>
<xml_diff>
--- a/BTP_MidSem_Presentation.pptx
+++ b/BTP_MidSem_Presentation.pptx
@@ -514,7 +514,8 @@
           <a:p>
             <a:r>
               <a:rPr lang="en-US" dirty="0"/>
-              <a:t/>
+              <a:t>NITESH - 10 s
+Greet, give the title once, name the three of us and the supervisor. Do not read the slide. Move on.</a:t>
             </a:r>
             <a:endParaRPr lang="en-US" dirty="0"/>
           </a:p>
@@ -602,7 +603,8 @@
           <a:p>
             <a:r>
               <a:rPr lang="en-US" dirty="0"/>
-              <a:t/>
+              <a:t>SAJAN - 50 s
+Deliver this confidently, not apologetically. I/Q imbalance destroys the cumulant features. But dispersion inverts our own headline: at 150 ps/nm the SVM scores 80.1% and the CNN 54.9%. We report it because it bounds the claim. If asked why it happens, say honestly that we have a hypothesis we have not tested - dispersion smears the local image structure the CNN relies on, while cumulants are computed over the whole capture. Do not invent certainty.</a:t>
             </a:r>
             <a:endParaRPr lang="en-US" dirty="0"/>
           </a:p>
@@ -690,7 +692,8 @@
           <a:p>
             <a:r>
               <a:rPr lang="en-US" dirty="0"/>
-              <a:t/>
+              <a:t>NITESH - 45 s
+Six lines; read the first and the last properly. The representation is the dominant design variable; the gap widens under mismatch; it also decides whether a confidence-gated monitor stays usable at all. End on the limitations line - stating them yourself is worth more than being asked.</a:t>
             </a:r>
             <a:endParaRPr lang="en-US" dirty="0"/>
           </a:p>
@@ -778,7 +781,8 @@
           <a:p>
             <a:r>
               <a:rPr lang="en-US" dirty="0"/>
-              <a:t/>
+              <a:t>NITESH - 25 s
+Manuscript is complete and compiles clean; targeting QPAIN 2027, deadline 30 November. Be straight that it is not submitted yet and needs a trim to the page limit. Mention the code is public and every number regenerates from a fixed seed.</a:t>
             </a:r>
             <a:endParaRPr lang="en-US" dirty="0"/>
           </a:p>
@@ -866,7 +870,8 @@
           <a:p>
             <a:r>
               <a:rPr lang="en-US" dirty="0"/>
-              <a:t/>
+              <a:t>ANY - 5 s
+Do not read these. Leave the slide up and say 'happy to take questions.' Keeping it on screen during Q&amp;A lets you point at a reference if challenged.</a:t>
             </a:r>
             <a:endParaRPr lang="en-US" dirty="0"/>
           </a:p>
@@ -954,7 +959,8 @@
           <a:p>
             <a:r>
               <a:rPr lang="en-US" dirty="0"/>
-              <a:t/>
+              <a:t>NITESH - 15 s
+One sentence: "I'll cover the problem and the literature, Yash takes the method, Sajan takes the results." Then advance. Do not read nine bullets aloud.</a:t>
             </a:r>
             <a:endParaRPr lang="en-US" dirty="0"/>
           </a:p>
@@ -1042,7 +1048,8 @@
           <a:p>
             <a:r>
               <a:rPr lang="en-US" dirty="0"/>
-              <a:t/>
+              <a:t>NITESH - 65 s
+Fibre carries data as light. Vary amplitude AND phase and one pulse carries several bits - that pulse is a symbol, the allowed set is the modulation format, and plotted on the I-Q plane it is the constellation diagram. Point at the picture: five formats down, noise decreasing to the right. Then the problem: modern networks switch format with link conditions, and the receiver cannot demodulate until it knows which one arrived. MFI works it out from the signal itself. PAUSE on the picture - it does the teaching for you.</a:t>
             </a:r>
             <a:endParaRPr lang="en-US" dirty="0"/>
           </a:p>
@@ -1130,7 +1137,8 @@
           <a:p>
             <a:r>
               <a:rPr lang="en-US" dirty="0"/>
-              <a:t/>
+              <a:t>NITESH - 60 s
+Four groups, one line each. Classical work uses cumulants because Gaussian noise cancels at fourth order and above. Others swapped in different hand-crafted representations. Then CNNs on constellation images, reported as a large gain. Wireless has asked a similar question - say that out loud, do not hide it. Land hard on the last bullet: every optical comparison changes the model and the input together, so nobody can say which caused the gain. That sentence sets up the whole talk.</a:t>
             </a:r>
             <a:endParaRPr lang="en-US" dirty="0"/>
           </a:p>
@@ -1218,7 +1226,8 @@
           <a:p>
             <a:r>
               <a:rPr lang="en-US" dirty="0"/>
-              <a:t/>
+              <a:t>YASH - 40 s
+Read the first objective properly; skim the rest. The point of this slide is that we set out to ANSWER a question, not to build a classifier. Twenty seconds on bullet one, twenty on the other five together.</a:t>
             </a:r>
             <a:endParaRPr lang="en-US" dirty="0"/>
           </a:p>
@@ -1306,7 +1315,8 @@
           <a:p>
             <a:r>
               <a:rPr lang="en-US" dirty="0"/>
-              <a:t/>
+              <a:t>YASH - 65 s
+We simulate the link - no public optical constellation dataset exists, and we need exactly controlled OSNR sweeps. Walk the signal chain quickly, then stop on validation: the fourth-order cumulant of a noiseless constellation is exact algebra, and our simulator reproduces it to within 0.004 for all five formats. That is the answer to 'how do you know your simulator is right?', so say it before they ask. Finish on the three representations coming from the SAME signal realisation - that is what makes the comparison fair.</a:t>
             </a:r>
             <a:endParaRPr lang="en-US" dirty="0"/>
           </a:p>
@@ -1394,7 +1404,8 @@
           <a:p>
             <a:r>
               <a:rPr lang="en-US" dirty="0"/>
-              <a:t/>
+              <a:t>YASH - 70 s
+This is the contribution slide. Spend the time. Walk the table out loud: across a row only the algorithm changes; down the deep-model column only the input changes. The MLP is the cell nobody fills - a trained deep network fed only the 15 features. Say why it settles the question either way: if it lands near the SVM, the representation matters; near the CNN, the model matters. Then the five classifiers and seven experiments in one breath.</a:t>
             </a:r>
             <a:endParaRPr lang="en-US" dirty="0"/>
           </a:p>
@@ -1482,7 +1493,8 @@
           <a:p>
             <a:r>
               <a:rPr lang="en-US" dirty="0"/>
-              <a:t/>
+              <a:t>SAJAN - 65 s
+Let them read the chart for three seconds before you speak. Three very different algorithms on identical features sit within 1.83 points of each other. The CNN on the image gains 5.32 over the strongest of them - 2.9 times as much. If asked why 5.32 and not 5.65: we compare against the BEST baseline, the SVM, because that is the harder test. Close on the MLP finishing below the SVM - depth on features bought nothing.</a:t>
             </a:r>
             <a:endParaRPr lang="en-US" dirty="0"/>
           </a:p>
@@ -1570,7 +1582,8 @@
           <a:p>
             <a:r>
               <a:rPr lang="en-US" dirty="0"/>
-              <a:t/>
+              <a:t>SAJAN - 70 s
+Two results here. First the margin: the CNN hits 95% at 7 dB where the SVM needs 14 - quote the margin, not the percentage, because it converts into reach or amplifier count. Then robustness, the strongest result: trained clean and tested severe, the CNN holds 89.8% while the SVM falls to 21.8% against a 20% chance level. Give the mechanism, not just the number - cumulants are statistics of an ASSUMED signal model. Then confidence: at a 90% gate the CNN still answers 86.9% of inputs, the SVM answers 0.2%.</a:t>
             </a:r>
             <a:endParaRPr lang="en-US" dirty="0"/>
           </a:p>

</xml_diff>

<commit_message>
State the Phase 2 plan instead of asking the committee to choose
Slide 9 previously closed by inviting the committee to pick which direction to
prioritise. That reads as not having decided. It now presents the same three
items as a numbered plan in priority order and closes with a statement:
Phase 2 begins with the nonlinearity experiment, because the Phase 1 robustness
result already fixes its design.

Same change in the report's Future Work section, and in the slide 9 speaker
note, which now says explicitly not to ask them to choose. If the committee
wants to redirect the work they will say so, and that is what FEEDBACK.md is for.

Co-Authored-By: Claude Opus 5 (1M context) <noreply@anthropic.com>
</commit_message>
<xml_diff>
--- a/BTP_MidSem_Presentation.pptx
+++ b/BTP_MidSem_Presentation.pptx
@@ -1493,7 +1493,7 @@
             <a:r>
               <a:rPr lang="en-US" dirty="0"/>
               <a:t>SAJAN - 60 s
-This slide does two jobs. First: four further experiments ARE complete - say complete, not 'planned' - with analysis in preparation. Give each one line, no more. If anyone asks for a number, give it immediately; never look evasive. Second: the three candidate directions. End by genuinely asking which they want prioritised, then STOP TALKING and let them answer. That question is the point of the slide.</a:t>
+This slide does two jobs. First: four further experiments ARE complete - say complete, not 'planned' - with analysis in preparation. One line each, no more. If anyone asks for a number, give it immediately; never look evasive. Second: state the Phase 2 plan with conviction. Do NOT ask them to choose. Say what you are doing and why nonlinearity is first. If they want to redirect you they will say so, and then you thank them and write it down. Asking a committee to pick for you invites the reading that you have not thought about it.</a:t>
             </a:r>
             <a:endParaRPr lang="en-US" dirty="0"/>
           </a:p>
@@ -6452,7 +6452,7 @@
                 <a:ea typeface="Times New Roman" pitchFamily="34" charset="-122"/>
                 <a:cs typeface="Times New Roman" pitchFamily="34" charset="-120"/>
               </a:rPr>
-              <a:t>Candidate directions for the remainder of the project:</a:t>
+              <a:t>Planned work for the remainder of the project:</a:t>
             </a:r>
             <a:endParaRPr lang="en-US" sz="1550" dirty="0"/>
           </a:p>
@@ -6487,15 +6487,15 @@
               <a:buChar char="▪"/>
             </a:pPr>
             <a:r>
-              <a:rPr lang="en-US" sz="1400" dirty="0">
-                <a:solidFill>
-                  <a:srgbClr val="000000"/>
-                </a:solidFill>
-                <a:latin typeface="Times New Roman" pitchFamily="34" charset="0"/>
-                <a:ea typeface="Times New Roman" pitchFamily="34" charset="-122"/>
-                <a:cs typeface="Times New Roman" pitchFamily="34" charset="-120"/>
-              </a:rPr>
-              <a:t>Fibre nonlinearity — our robustness result makes a specific, testable prediction, since nonlinear interference is not Gaussian.</a:t>
+              <a:rPr lang="en-US" sz="1400" b="1" dirty="0">
+                <a:solidFill>
+                  <a:srgbClr val="000000"/>
+                </a:solidFill>
+                <a:latin typeface="Times New Roman" pitchFamily="34" charset="0"/>
+                <a:ea typeface="Times New Roman" pitchFamily="34" charset="-122"/>
+                <a:cs typeface="Times New Roman" pitchFamily="34" charset="-120"/>
+              </a:rPr>
+              <a:t>1.  Fibre nonlinearity. Our robustness result already makes a falsifiable prediction here — nonlinear interference is not Gaussian, so the feature-based models should degrade further. We begin with this.</a:t>
             </a:r>
             <a:endParaRPr lang="en-US" sz="1400" dirty="0"/>
           </a:p>
@@ -6516,7 +6516,7 @@
                 <a:ea typeface="Times New Roman" pitchFamily="34" charset="-122"/>
                 <a:cs typeface="Times New Roman" pitchFamily="34" charset="-120"/>
               </a:rPr>
-              <a:t>Polarisation-multiplexed signals — the principal realism gap against deployed systems.</a:t>
+              <a:t>2.  Polarisation-multiplexed signals, closing the principal realism gap against deployed systems.</a:t>
             </a:r>
             <a:endParaRPr lang="en-US" sz="1400" dirty="0"/>
           </a:p>
@@ -6537,7 +6537,7 @@
                 <a:ea typeface="Times New Roman" pitchFamily="34" charset="-122"/>
                 <a:cs typeface="Times New Roman" pitchFamily="34" charset="-120"/>
               </a:rPr>
-              <a:t>Explaining the chromatic dispersion case, where our own result inverts.</a:t>
+              <a:t>3.  Establishing the mechanism behind the chromatic dispersion case, where our own result inverts.</a:t>
             </a:r>
             <a:endParaRPr lang="en-US" sz="1400" dirty="0"/>
           </a:p>
@@ -6576,7 +6576,7 @@
                 <a:ea typeface="Times New Roman" pitchFamily="34" charset="-122"/>
                 <a:cs typeface="Times New Roman" pitchFamily="34" charset="-120"/>
               </a:rPr>
-              <a:t>We would welcome the committee’s guidance on which of these to prioritise.</a:t>
+              <a:t>Phase 2 begins with the nonlinearity experiment; its design is already fixed by the Phase 1 result.</a:t>
             </a:r>
             <a:endParaRPr lang="en-US" sz="1550" dirty="0"/>
           </a:p>

</xml_diff>